<commit_message>
website updated 20260614 22:34
</commit_message>
<xml_diff>
--- a/files/Shiny code.pptx
+++ b/files/Shiny code.pptx
@@ -6,18 +6,20 @@
   </p:sldMasterIdLst>
   <p:sldIdLst>
     <p:sldId id="256" r:id="rId2"/>
-    <p:sldId id="257" r:id="rId3"/>
-    <p:sldId id="268" r:id="rId4"/>
-    <p:sldId id="267" r:id="rId5"/>
-    <p:sldId id="259" r:id="rId6"/>
-    <p:sldId id="258" r:id="rId7"/>
-    <p:sldId id="260" r:id="rId8"/>
-    <p:sldId id="261" r:id="rId9"/>
-    <p:sldId id="262" r:id="rId10"/>
-    <p:sldId id="264" r:id="rId11"/>
-    <p:sldId id="265" r:id="rId12"/>
-    <p:sldId id="266" r:id="rId13"/>
-    <p:sldId id="263" r:id="rId14"/>
+    <p:sldId id="270" r:id="rId3"/>
+    <p:sldId id="257" r:id="rId4"/>
+    <p:sldId id="268" r:id="rId5"/>
+    <p:sldId id="267" r:id="rId6"/>
+    <p:sldId id="269" r:id="rId7"/>
+    <p:sldId id="259" r:id="rId8"/>
+    <p:sldId id="258" r:id="rId9"/>
+    <p:sldId id="260" r:id="rId10"/>
+    <p:sldId id="261" r:id="rId11"/>
+    <p:sldId id="262" r:id="rId12"/>
+    <p:sldId id="264" r:id="rId13"/>
+    <p:sldId id="265" r:id="rId14"/>
+    <p:sldId id="266" r:id="rId15"/>
+    <p:sldId id="263" r:id="rId16"/>
   </p:sldIdLst>
   <p:sldSz cx="12192000" cy="6858000"/>
   <p:notesSz cx="6858000" cy="9144000"/>
@@ -271,7 +273,7 @@
           <a:p>
             <a:fld id="{DCFD41A1-FF43-4EEC-9EF6-8AF6F445BC2D}" type="datetimeFigureOut">
               <a:rPr lang="zh-TW" altLang="en-US" smtClean="0"/>
-              <a:t>2026/6/11</a:t>
+              <a:t>2026/6/12</a:t>
             </a:fld>
             <a:endParaRPr lang="zh-TW" altLang="en-US"/>
           </a:p>
@@ -469,7 +471,7 @@
           <a:p>
             <a:fld id="{DCFD41A1-FF43-4EEC-9EF6-8AF6F445BC2D}" type="datetimeFigureOut">
               <a:rPr lang="zh-TW" altLang="en-US" smtClean="0"/>
-              <a:t>2026/6/11</a:t>
+              <a:t>2026/6/12</a:t>
             </a:fld>
             <a:endParaRPr lang="zh-TW" altLang="en-US"/>
           </a:p>
@@ -677,7 +679,7 @@
           <a:p>
             <a:fld id="{DCFD41A1-FF43-4EEC-9EF6-8AF6F445BC2D}" type="datetimeFigureOut">
               <a:rPr lang="zh-TW" altLang="en-US" smtClean="0"/>
-              <a:t>2026/6/11</a:t>
+              <a:t>2026/6/12</a:t>
             </a:fld>
             <a:endParaRPr lang="zh-TW" altLang="en-US"/>
           </a:p>
@@ -875,7 +877,7 @@
           <a:p>
             <a:fld id="{DCFD41A1-FF43-4EEC-9EF6-8AF6F445BC2D}" type="datetimeFigureOut">
               <a:rPr lang="zh-TW" altLang="en-US" smtClean="0"/>
-              <a:t>2026/6/11</a:t>
+              <a:t>2026/6/12</a:t>
             </a:fld>
             <a:endParaRPr lang="zh-TW" altLang="en-US"/>
           </a:p>
@@ -1150,7 +1152,7 @@
           <a:p>
             <a:fld id="{DCFD41A1-FF43-4EEC-9EF6-8AF6F445BC2D}" type="datetimeFigureOut">
               <a:rPr lang="zh-TW" altLang="en-US" smtClean="0"/>
-              <a:t>2026/6/11</a:t>
+              <a:t>2026/6/12</a:t>
             </a:fld>
             <a:endParaRPr lang="zh-TW" altLang="en-US"/>
           </a:p>
@@ -1415,7 +1417,7 @@
           <a:p>
             <a:fld id="{DCFD41A1-FF43-4EEC-9EF6-8AF6F445BC2D}" type="datetimeFigureOut">
               <a:rPr lang="zh-TW" altLang="en-US" smtClean="0"/>
-              <a:t>2026/6/11</a:t>
+              <a:t>2026/6/12</a:t>
             </a:fld>
             <a:endParaRPr lang="zh-TW" altLang="en-US"/>
           </a:p>
@@ -1827,7 +1829,7 @@
           <a:p>
             <a:fld id="{DCFD41A1-FF43-4EEC-9EF6-8AF6F445BC2D}" type="datetimeFigureOut">
               <a:rPr lang="zh-TW" altLang="en-US" smtClean="0"/>
-              <a:t>2026/6/11</a:t>
+              <a:t>2026/6/12</a:t>
             </a:fld>
             <a:endParaRPr lang="zh-TW" altLang="en-US"/>
           </a:p>
@@ -1968,7 +1970,7 @@
           <a:p>
             <a:fld id="{DCFD41A1-FF43-4EEC-9EF6-8AF6F445BC2D}" type="datetimeFigureOut">
               <a:rPr lang="zh-TW" altLang="en-US" smtClean="0"/>
-              <a:t>2026/6/11</a:t>
+              <a:t>2026/6/12</a:t>
             </a:fld>
             <a:endParaRPr lang="zh-TW" altLang="en-US"/>
           </a:p>
@@ -2081,7 +2083,7 @@
           <a:p>
             <a:fld id="{DCFD41A1-FF43-4EEC-9EF6-8AF6F445BC2D}" type="datetimeFigureOut">
               <a:rPr lang="zh-TW" altLang="en-US" smtClean="0"/>
-              <a:t>2026/6/11</a:t>
+              <a:t>2026/6/12</a:t>
             </a:fld>
             <a:endParaRPr lang="zh-TW" altLang="en-US"/>
           </a:p>
@@ -2392,7 +2394,7 @@
           <a:p>
             <a:fld id="{DCFD41A1-FF43-4EEC-9EF6-8AF6F445BC2D}" type="datetimeFigureOut">
               <a:rPr lang="zh-TW" altLang="en-US" smtClean="0"/>
-              <a:t>2026/6/11</a:t>
+              <a:t>2026/6/12</a:t>
             </a:fld>
             <a:endParaRPr lang="zh-TW" altLang="en-US"/>
           </a:p>
@@ -2680,7 +2682,7 @@
           <a:p>
             <a:fld id="{DCFD41A1-FF43-4EEC-9EF6-8AF6F445BC2D}" type="datetimeFigureOut">
               <a:rPr lang="zh-TW" altLang="en-US" smtClean="0"/>
-              <a:t>2026/6/11</a:t>
+              <a:t>2026/6/12</a:t>
             </a:fld>
             <a:endParaRPr lang="zh-TW" altLang="en-US"/>
           </a:p>
@@ -2921,7 +2923,7 @@
           <a:p>
             <a:fld id="{DCFD41A1-FF43-4EEC-9EF6-8AF6F445BC2D}" type="datetimeFigureOut">
               <a:rPr lang="zh-TW" altLang="en-US" smtClean="0"/>
-              <a:t>2026/6/11</a:t>
+              <a:t>2026/6/12</a:t>
             </a:fld>
             <a:endParaRPr lang="zh-TW" altLang="en-US"/>
           </a:p>
@@ -3649,7 +3651,7 @@
         <p:cNvPr id="1" name="">
           <a:extLst>
             <a:ext uri="{FF2B5EF4-FFF2-40B4-BE49-F238E27FC236}">
-              <a16:creationId xmlns:a16="http://schemas.microsoft.com/office/drawing/2014/main" id="{D90D0109-7A52-1201-C676-A4B5EDBD781C}"/>
+              <a16:creationId xmlns:a16="http://schemas.microsoft.com/office/drawing/2014/main" id="{EFEBAEEC-72AC-351A-421B-C1910F2A8EC4}"/>
             </a:ext>
           </a:extLst>
         </p:cNvPr>
@@ -3669,7 +3671,7 @@
           <p:cNvPr id="3" name="文字方塊 2">
             <a:extLst>
               <a:ext uri="{FF2B5EF4-FFF2-40B4-BE49-F238E27FC236}">
-                <a16:creationId xmlns:a16="http://schemas.microsoft.com/office/drawing/2014/main" id="{8D446CD3-07FB-C3E7-748D-42DB12842FC2}"/>
+                <a16:creationId xmlns:a16="http://schemas.microsoft.com/office/drawing/2014/main" id="{FBA40D14-B996-9EDB-E4C2-83528485C334}"/>
               </a:ext>
             </a:extLst>
           </p:cNvPr>
@@ -3702,7 +3704,7 @@
                   <a:srgbClr val="FF0000"/>
                 </a:solidFill>
               </a:rPr>
-              <a:t>selectizeInput</a:t>
+              <a:t>fileInput</a:t>
             </a:r>
             <a:r>
               <a:rPr lang="en-US" altLang="zh-TW" i="0">
@@ -3843,7 +3845,7 @@
           <p:cNvPr id="7" name="文字方塊 6">
             <a:extLst>
               <a:ext uri="{FF2B5EF4-FFF2-40B4-BE49-F238E27FC236}">
-                <a16:creationId xmlns:a16="http://schemas.microsoft.com/office/drawing/2014/main" id="{CF4322A7-B279-FCCC-C1F9-5D56AC5B0709}"/>
+                <a16:creationId xmlns:a16="http://schemas.microsoft.com/office/drawing/2014/main" id="{921EB90A-1652-8947-21EA-EFB2AF8E7B36}"/>
               </a:ext>
             </a:extLst>
           </p:cNvPr>
@@ -3872,7 +3874,7 @@
                   <a:srgbClr val="FF0000"/>
                 </a:solidFill>
               </a:rPr>
-              <a:t>selectizeInput</a:t>
+              <a:t>fileInput</a:t>
             </a:r>
             <a:r>
               <a:rPr lang="zh-TW" altLang="zh-TW"/>
@@ -3903,7 +3905,7 @@
           <p:cNvPr id="9" name="圖片 8">
             <a:extLst>
               <a:ext uri="{FF2B5EF4-FFF2-40B4-BE49-F238E27FC236}">
-                <a16:creationId xmlns:a16="http://schemas.microsoft.com/office/drawing/2014/main" id="{A9AA0EA3-8DC4-A93C-F1E7-4046AED82B08}"/>
+                <a16:creationId xmlns:a16="http://schemas.microsoft.com/office/drawing/2014/main" id="{DEC1CDF0-2F7B-3998-CF8B-7152111791D9}"/>
               </a:ext>
             </a:extLst>
           </p:cNvPr>
@@ -3933,6 +3935,690 @@
           <p:cNvPr id="19" name="文字方塊 18">
             <a:extLst>
               <a:ext uri="{FF2B5EF4-FFF2-40B4-BE49-F238E27FC236}">
+                <a16:creationId xmlns:a16="http://schemas.microsoft.com/office/drawing/2014/main" id="{CE53DA03-D6B9-03A0-076C-55DA07FB3E87}"/>
+              </a:ext>
+            </a:extLst>
+          </p:cNvPr>
+          <p:cNvSpPr txBox="1"/>
+          <p:nvPr/>
+        </p:nvSpPr>
+        <p:spPr>
+          <a:xfrm>
+            <a:off x="521110" y="3429000"/>
+            <a:ext cx="3097161" cy="461665"/>
+          </a:xfrm>
+          <a:prstGeom prst="rect">
+            <a:avLst/>
+          </a:prstGeom>
+          <a:noFill/>
+        </p:spPr>
+        <p:txBody>
+          <a:bodyPr wrap="square" rtlCol="0">
+            <a:spAutoFit/>
+          </a:bodyPr>
+          <a:lstStyle/>
+          <a:p>
+            <a:r>
+              <a:rPr lang="en-US" altLang="zh-TW" sz="2400">
+                <a:latin typeface="Arial" panose="020B0604020202020204" pitchFamily="34" charset="0"/>
+                <a:cs typeface="Arial" panose="020B0604020202020204" pitchFamily="34" charset="0"/>
+              </a:rPr>
+              <a:t>Example: </a:t>
+            </a:r>
+            <a:endParaRPr lang="zh-TW" altLang="en-US" sz="2400">
+              <a:latin typeface="Arial" panose="020B0604020202020204" pitchFamily="34" charset="0"/>
+              <a:cs typeface="Arial" panose="020B0604020202020204" pitchFamily="34" charset="0"/>
+            </a:endParaRPr>
+          </a:p>
+        </p:txBody>
+      </p:sp>
+    </p:spTree>
+    <p:extLst>
+      <p:ext uri="{BB962C8B-B14F-4D97-AF65-F5344CB8AC3E}">
+        <p14:creationId xmlns:p14="http://schemas.microsoft.com/office/powerpoint/2010/main" val="1947664966"/>
+      </p:ext>
+    </p:extLst>
+  </p:cSld>
+  <p:clrMapOvr>
+    <a:masterClrMapping/>
+  </p:clrMapOvr>
+</p:sld>
+</file>
+
+<file path=ppt/slides/slide11.xml><?xml version="1.0" encoding="utf-8"?>
+<p:sld xmlns:a="http://schemas.openxmlformats.org/drawingml/2006/main" xmlns:r="http://schemas.openxmlformats.org/officeDocument/2006/relationships" xmlns:p="http://schemas.openxmlformats.org/presentationml/2006/main">
+  <p:cSld>
+    <p:spTree>
+      <p:nvGrpSpPr>
+        <p:cNvPr id="1" name="">
+          <a:extLst>
+            <a:ext uri="{FF2B5EF4-FFF2-40B4-BE49-F238E27FC236}">
+              <a16:creationId xmlns:a16="http://schemas.microsoft.com/office/drawing/2014/main" id="{D7191584-B73A-2264-60D2-9906AA8FEEE0}"/>
+            </a:ext>
+          </a:extLst>
+        </p:cNvPr>
+        <p:cNvGrpSpPr/>
+        <p:nvPr/>
+      </p:nvGrpSpPr>
+      <p:grpSpPr>
+        <a:xfrm>
+          <a:off x="0" y="0"/>
+          <a:ext cx="0" cy="0"/>
+          <a:chOff x="0" y="0"/>
+          <a:chExt cx="0" cy="0"/>
+        </a:xfrm>
+      </p:grpSpPr>
+      <p:sp>
+        <p:nvSpPr>
+          <p:cNvPr id="3" name="文字方塊 2">
+            <a:extLst>
+              <a:ext uri="{FF2B5EF4-FFF2-40B4-BE49-F238E27FC236}">
+                <a16:creationId xmlns:a16="http://schemas.microsoft.com/office/drawing/2014/main" id="{8E5C9E97-906A-531B-CCD4-8E7B313AA44C}"/>
+              </a:ext>
+            </a:extLst>
+          </p:cNvPr>
+          <p:cNvSpPr txBox="1"/>
+          <p:nvPr/>
+        </p:nvSpPr>
+        <p:spPr>
+          <a:xfrm>
+            <a:off x="196649" y="278749"/>
+            <a:ext cx="11867532" cy="1200329"/>
+          </a:xfrm>
+          <a:prstGeom prst="rect">
+            <a:avLst/>
+          </a:prstGeom>
+          <a:noFill/>
+        </p:spPr>
+        <p:txBody>
+          <a:bodyPr wrap="square">
+            <a:spAutoFit/>
+          </a:bodyPr>
+          <a:lstStyle/>
+          <a:p>
+            <a:pPr marL="285750" indent="-285750">
+              <a:buFont typeface="Arial" panose="020B0604020202020204" pitchFamily="34" charset="0"/>
+              <a:buChar char="•"/>
+            </a:pPr>
+            <a:r>
+              <a:rPr lang="en-US" altLang="zh-TW">
+                <a:solidFill>
+                  <a:srgbClr val="FF0000"/>
+                </a:solidFill>
+              </a:rPr>
+              <a:t>selectInput</a:t>
+            </a:r>
+            <a:r>
+              <a:rPr lang="en-US" altLang="zh-TW" i="0">
+                <a:solidFill>
+                  <a:srgbClr val="000000"/>
+                </a:solidFill>
+                <a:effectLst/>
+              </a:rPr>
+              <a:t>:</a:t>
+            </a:r>
+            <a:r>
+              <a:rPr lang="zh-TW" altLang="en-US" i="0">
+                <a:solidFill>
+                  <a:srgbClr val="000000"/>
+                </a:solidFill>
+                <a:effectLst/>
+              </a:rPr>
+              <a:t> </a:t>
+            </a:r>
+            <a:endParaRPr lang="en-US" altLang="zh-TW">
+              <a:solidFill>
+                <a:srgbClr val="000000"/>
+              </a:solidFill>
+              <a:latin typeface="Arial" panose="020B0604020202020204" pitchFamily="34" charset="0"/>
+            </a:endParaRPr>
+          </a:p>
+          <a:p>
+            <a:pPr marL="742950" lvl="1" indent="-285750">
+              <a:buFont typeface="Arial" panose="020B0604020202020204" pitchFamily="34" charset="0"/>
+              <a:buChar char="•"/>
+            </a:pPr>
+            <a:r>
+              <a:rPr lang="en-US" altLang="zh-TW">
+                <a:solidFill>
+                  <a:srgbClr val="000000"/>
+                </a:solidFill>
+              </a:rPr>
+              <a:t>inputId: </a:t>
+            </a:r>
+            <a:r>
+              <a:rPr lang="zh-TW" altLang="zh-TW">
+                <a:latin typeface="Arial" panose="020B0604020202020204" pitchFamily="34" charset="0"/>
+                <a:cs typeface="Arial" panose="020B0604020202020204" pitchFamily="34" charset="0"/>
+              </a:rPr>
+              <a:t>The input slot that will be used to access the value.</a:t>
+            </a:r>
+            <a:endParaRPr lang="en-US" altLang="zh-TW">
+              <a:solidFill>
+                <a:srgbClr val="000000"/>
+              </a:solidFill>
+              <a:latin typeface="Arial" panose="020B0604020202020204" pitchFamily="34" charset="0"/>
+              <a:cs typeface="Arial" panose="020B0604020202020204" pitchFamily="34" charset="0"/>
+            </a:endParaRPr>
+          </a:p>
+          <a:p>
+            <a:pPr marL="742950" lvl="1" indent="-285750">
+              <a:buFont typeface="Arial" panose="020B0604020202020204" pitchFamily="34" charset="0"/>
+              <a:buChar char="•"/>
+            </a:pPr>
+            <a:r>
+              <a:rPr lang="en-US" altLang="zh-TW">
+                <a:solidFill>
+                  <a:srgbClr val="000000"/>
+                </a:solidFill>
+              </a:rPr>
+              <a:t>label: </a:t>
+            </a:r>
+            <a:r>
+              <a:rPr lang="zh-TW" altLang="en-US">
+                <a:solidFill>
+                  <a:srgbClr val="000000"/>
+                </a:solidFill>
+              </a:rPr>
+              <a:t>標題 </a:t>
+            </a:r>
+            <a:r>
+              <a:rPr lang="zh-TW" altLang="zh-TW">
+                <a:latin typeface="Arial" panose="020B0604020202020204" pitchFamily="34" charset="0"/>
+                <a:cs typeface="Arial" panose="020B0604020202020204" pitchFamily="34" charset="0"/>
+              </a:rPr>
+              <a:t>Display label for the control</a:t>
+            </a:r>
+            <a:r>
+              <a:rPr lang="en-US" altLang="zh-TW">
+                <a:latin typeface="Arial" panose="020B0604020202020204" pitchFamily="34" charset="0"/>
+                <a:cs typeface="Arial" panose="020B0604020202020204" pitchFamily="34" charset="0"/>
+              </a:rPr>
+              <a:t>.</a:t>
+            </a:r>
+            <a:endParaRPr lang="en-US" altLang="zh-TW">
+              <a:solidFill>
+                <a:srgbClr val="000000"/>
+              </a:solidFill>
+              <a:latin typeface="Arial" panose="020B0604020202020204" pitchFamily="34" charset="0"/>
+              <a:cs typeface="Arial" panose="020B0604020202020204" pitchFamily="34" charset="0"/>
+            </a:endParaRPr>
+          </a:p>
+          <a:p>
+            <a:pPr marL="742950" lvl="1" indent="-285750">
+              <a:buFont typeface="Arial" panose="020B0604020202020204" pitchFamily="34" charset="0"/>
+              <a:buChar char="•"/>
+            </a:pPr>
+            <a:r>
+              <a:rPr lang="en-US" altLang="zh-TW">
+                <a:solidFill>
+                  <a:srgbClr val="000000"/>
+                </a:solidFill>
+              </a:rPr>
+              <a:t>value: </a:t>
+            </a:r>
+            <a:r>
+              <a:rPr lang="zh-TW" altLang="en-US">
+                <a:solidFill>
+                  <a:srgbClr val="000000"/>
+                </a:solidFill>
+              </a:rPr>
+              <a:t>初始值 </a:t>
+            </a:r>
+            <a:r>
+              <a:rPr lang="zh-TW" altLang="zh-TW">
+                <a:latin typeface="Arial" panose="020B0604020202020204" pitchFamily="34" charset="0"/>
+                <a:cs typeface="Arial" panose="020B0604020202020204" pitchFamily="34" charset="0"/>
+              </a:rPr>
+              <a:t>Initial value.</a:t>
+            </a:r>
+            <a:endParaRPr lang="en-US" altLang="zh-TW">
+              <a:solidFill>
+                <a:srgbClr val="000000"/>
+              </a:solidFill>
+              <a:latin typeface="Arial" panose="020B0604020202020204" pitchFamily="34" charset="0"/>
+              <a:cs typeface="Arial" panose="020B0604020202020204" pitchFamily="34" charset="0"/>
+            </a:endParaRPr>
+          </a:p>
+        </p:txBody>
+      </p:sp>
+      <p:sp>
+        <p:nvSpPr>
+          <p:cNvPr id="7" name="文字方塊 6">
+            <a:extLst>
+              <a:ext uri="{FF2B5EF4-FFF2-40B4-BE49-F238E27FC236}">
+                <a16:creationId xmlns:a16="http://schemas.microsoft.com/office/drawing/2014/main" id="{1BC3CB37-C489-F12B-25DB-08AAA4230C3F}"/>
+              </a:ext>
+            </a:extLst>
+          </p:cNvPr>
+          <p:cNvSpPr txBox="1"/>
+          <p:nvPr/>
+        </p:nvSpPr>
+        <p:spPr>
+          <a:xfrm>
+            <a:off x="521109" y="4220048"/>
+            <a:ext cx="10736825" cy="369332"/>
+          </a:xfrm>
+          <a:prstGeom prst="rect">
+            <a:avLst/>
+          </a:prstGeom>
+          <a:noFill/>
+        </p:spPr>
+        <p:txBody>
+          <a:bodyPr wrap="square">
+            <a:spAutoFit/>
+          </a:bodyPr>
+          <a:lstStyle/>
+          <a:p>
+            <a:r>
+              <a:rPr lang="en-US" altLang="zh-TW">
+                <a:solidFill>
+                  <a:srgbClr val="FF0000"/>
+                </a:solidFill>
+              </a:rPr>
+              <a:t>selectInput</a:t>
+            </a:r>
+            <a:r>
+              <a:rPr lang="zh-TW" altLang="zh-TW"/>
+              <a:t>(</a:t>
+            </a:r>
+            <a:r>
+              <a:rPr lang="en-US" altLang="zh-TW"/>
+              <a:t>inputId = </a:t>
+            </a:r>
+            <a:r>
+              <a:rPr lang="zh-TW" altLang="zh-TW"/>
+              <a:t>"name", </a:t>
+            </a:r>
+            <a:r>
+              <a:rPr lang="en-US" altLang="zh-TW"/>
+              <a:t>label = </a:t>
+            </a:r>
+            <a:r>
+              <a:rPr lang="zh-TW" altLang="zh-TW"/>
+              <a:t>"Your full name", value = "John Smith")</a:t>
+            </a:r>
+            <a:endParaRPr lang="zh-TW" altLang="en-US"/>
+          </a:p>
+        </p:txBody>
+      </p:sp>
+      <p:pic>
+        <p:nvPicPr>
+          <p:cNvPr id="9" name="圖片 8">
+            <a:extLst>
+              <a:ext uri="{FF2B5EF4-FFF2-40B4-BE49-F238E27FC236}">
+                <a16:creationId xmlns:a16="http://schemas.microsoft.com/office/drawing/2014/main" id="{052AB2CA-1CA4-B0F8-F7B6-8D200AE77FBA}"/>
+              </a:ext>
+            </a:extLst>
+          </p:cNvPr>
+          <p:cNvPicPr>
+            <a:picLocks noChangeAspect="1"/>
+          </p:cNvPicPr>
+          <p:nvPr/>
+        </p:nvPicPr>
+        <p:blipFill>
+          <a:blip r:embed="rId2"/>
+          <a:stretch>
+            <a:fillRect/>
+          </a:stretch>
+        </p:blipFill>
+        <p:spPr>
+          <a:xfrm>
+            <a:off x="3992697" y="4855602"/>
+            <a:ext cx="4206605" cy="1089754"/>
+          </a:xfrm>
+          <a:prstGeom prst="rect">
+            <a:avLst/>
+          </a:prstGeom>
+        </p:spPr>
+      </p:pic>
+      <p:sp>
+        <p:nvSpPr>
+          <p:cNvPr id="19" name="文字方塊 18">
+            <a:extLst>
+              <a:ext uri="{FF2B5EF4-FFF2-40B4-BE49-F238E27FC236}">
+                <a16:creationId xmlns:a16="http://schemas.microsoft.com/office/drawing/2014/main" id="{581C790A-BA5E-6DC1-6A10-09CCB900C60F}"/>
+              </a:ext>
+            </a:extLst>
+          </p:cNvPr>
+          <p:cNvSpPr txBox="1"/>
+          <p:nvPr/>
+        </p:nvSpPr>
+        <p:spPr>
+          <a:xfrm>
+            <a:off x="521110" y="3429000"/>
+            <a:ext cx="3097161" cy="461665"/>
+          </a:xfrm>
+          <a:prstGeom prst="rect">
+            <a:avLst/>
+          </a:prstGeom>
+          <a:noFill/>
+        </p:spPr>
+        <p:txBody>
+          <a:bodyPr wrap="square" rtlCol="0">
+            <a:spAutoFit/>
+          </a:bodyPr>
+          <a:lstStyle/>
+          <a:p>
+            <a:r>
+              <a:rPr lang="en-US" altLang="zh-TW" sz="2400">
+                <a:latin typeface="Arial" panose="020B0604020202020204" pitchFamily="34" charset="0"/>
+                <a:cs typeface="Arial" panose="020B0604020202020204" pitchFamily="34" charset="0"/>
+              </a:rPr>
+              <a:t>Example: </a:t>
+            </a:r>
+            <a:endParaRPr lang="zh-TW" altLang="en-US" sz="2400">
+              <a:latin typeface="Arial" panose="020B0604020202020204" pitchFamily="34" charset="0"/>
+              <a:cs typeface="Arial" panose="020B0604020202020204" pitchFamily="34" charset="0"/>
+            </a:endParaRPr>
+          </a:p>
+        </p:txBody>
+      </p:sp>
+    </p:spTree>
+    <p:extLst>
+      <p:ext uri="{BB962C8B-B14F-4D97-AF65-F5344CB8AC3E}">
+        <p14:creationId xmlns:p14="http://schemas.microsoft.com/office/powerpoint/2010/main" val="967130390"/>
+      </p:ext>
+    </p:extLst>
+  </p:cSld>
+  <p:clrMapOvr>
+    <a:masterClrMapping/>
+  </p:clrMapOvr>
+</p:sld>
+</file>
+
+<file path=ppt/slides/slide12.xml><?xml version="1.0" encoding="utf-8"?>
+<p:sld xmlns:a="http://schemas.openxmlformats.org/drawingml/2006/main" xmlns:r="http://schemas.openxmlformats.org/officeDocument/2006/relationships" xmlns:p="http://schemas.openxmlformats.org/presentationml/2006/main">
+  <p:cSld>
+    <p:spTree>
+      <p:nvGrpSpPr>
+        <p:cNvPr id="1" name="">
+          <a:extLst>
+            <a:ext uri="{FF2B5EF4-FFF2-40B4-BE49-F238E27FC236}">
+              <a16:creationId xmlns:a16="http://schemas.microsoft.com/office/drawing/2014/main" id="{D90D0109-7A52-1201-C676-A4B5EDBD781C}"/>
+            </a:ext>
+          </a:extLst>
+        </p:cNvPr>
+        <p:cNvGrpSpPr/>
+        <p:nvPr/>
+      </p:nvGrpSpPr>
+      <p:grpSpPr>
+        <a:xfrm>
+          <a:off x="0" y="0"/>
+          <a:ext cx="0" cy="0"/>
+          <a:chOff x="0" y="0"/>
+          <a:chExt cx="0" cy="0"/>
+        </a:xfrm>
+      </p:grpSpPr>
+      <p:sp>
+        <p:nvSpPr>
+          <p:cNvPr id="3" name="文字方塊 2">
+            <a:extLst>
+              <a:ext uri="{FF2B5EF4-FFF2-40B4-BE49-F238E27FC236}">
+                <a16:creationId xmlns:a16="http://schemas.microsoft.com/office/drawing/2014/main" id="{8D446CD3-07FB-C3E7-748D-42DB12842FC2}"/>
+              </a:ext>
+            </a:extLst>
+          </p:cNvPr>
+          <p:cNvSpPr txBox="1"/>
+          <p:nvPr/>
+        </p:nvSpPr>
+        <p:spPr>
+          <a:xfrm>
+            <a:off x="196649" y="278749"/>
+            <a:ext cx="11867532" cy="1200329"/>
+          </a:xfrm>
+          <a:prstGeom prst="rect">
+            <a:avLst/>
+          </a:prstGeom>
+          <a:noFill/>
+        </p:spPr>
+        <p:txBody>
+          <a:bodyPr wrap="square">
+            <a:spAutoFit/>
+          </a:bodyPr>
+          <a:lstStyle/>
+          <a:p>
+            <a:pPr marL="285750" indent="-285750">
+              <a:buFont typeface="Arial" panose="020B0604020202020204" pitchFamily="34" charset="0"/>
+              <a:buChar char="•"/>
+            </a:pPr>
+            <a:r>
+              <a:rPr lang="en-US" altLang="zh-TW">
+                <a:solidFill>
+                  <a:srgbClr val="FF0000"/>
+                </a:solidFill>
+              </a:rPr>
+              <a:t>selectizeInput</a:t>
+            </a:r>
+            <a:r>
+              <a:rPr lang="en-US" altLang="zh-TW" i="0">
+                <a:solidFill>
+                  <a:srgbClr val="000000"/>
+                </a:solidFill>
+                <a:effectLst/>
+              </a:rPr>
+              <a:t>:</a:t>
+            </a:r>
+            <a:r>
+              <a:rPr lang="zh-TW" altLang="en-US" i="0">
+                <a:solidFill>
+                  <a:srgbClr val="000000"/>
+                </a:solidFill>
+                <a:effectLst/>
+              </a:rPr>
+              <a:t> </a:t>
+            </a:r>
+            <a:endParaRPr lang="en-US" altLang="zh-TW">
+              <a:solidFill>
+                <a:srgbClr val="000000"/>
+              </a:solidFill>
+              <a:latin typeface="Arial" panose="020B0604020202020204" pitchFamily="34" charset="0"/>
+            </a:endParaRPr>
+          </a:p>
+          <a:p>
+            <a:pPr marL="742950" lvl="1" indent="-285750">
+              <a:buFont typeface="Arial" panose="020B0604020202020204" pitchFamily="34" charset="0"/>
+              <a:buChar char="•"/>
+            </a:pPr>
+            <a:r>
+              <a:rPr lang="en-US" altLang="zh-TW">
+                <a:solidFill>
+                  <a:srgbClr val="000000"/>
+                </a:solidFill>
+              </a:rPr>
+              <a:t>inputId: </a:t>
+            </a:r>
+            <a:r>
+              <a:rPr lang="zh-TW" altLang="zh-TW">
+                <a:latin typeface="Arial" panose="020B0604020202020204" pitchFamily="34" charset="0"/>
+                <a:cs typeface="Arial" panose="020B0604020202020204" pitchFamily="34" charset="0"/>
+              </a:rPr>
+              <a:t>The input slot that will be used to access the value.</a:t>
+            </a:r>
+            <a:endParaRPr lang="en-US" altLang="zh-TW">
+              <a:solidFill>
+                <a:srgbClr val="000000"/>
+              </a:solidFill>
+              <a:latin typeface="Arial" panose="020B0604020202020204" pitchFamily="34" charset="0"/>
+              <a:cs typeface="Arial" panose="020B0604020202020204" pitchFamily="34" charset="0"/>
+            </a:endParaRPr>
+          </a:p>
+          <a:p>
+            <a:pPr marL="742950" lvl="1" indent="-285750">
+              <a:buFont typeface="Arial" panose="020B0604020202020204" pitchFamily="34" charset="0"/>
+              <a:buChar char="•"/>
+            </a:pPr>
+            <a:r>
+              <a:rPr lang="en-US" altLang="zh-TW">
+                <a:solidFill>
+                  <a:srgbClr val="000000"/>
+                </a:solidFill>
+              </a:rPr>
+              <a:t>label: </a:t>
+            </a:r>
+            <a:r>
+              <a:rPr lang="zh-TW" altLang="en-US">
+                <a:solidFill>
+                  <a:srgbClr val="000000"/>
+                </a:solidFill>
+              </a:rPr>
+              <a:t>標題 </a:t>
+            </a:r>
+            <a:r>
+              <a:rPr lang="zh-TW" altLang="zh-TW">
+                <a:latin typeface="Arial" panose="020B0604020202020204" pitchFamily="34" charset="0"/>
+                <a:cs typeface="Arial" panose="020B0604020202020204" pitchFamily="34" charset="0"/>
+              </a:rPr>
+              <a:t>Display label for the control</a:t>
+            </a:r>
+            <a:r>
+              <a:rPr lang="en-US" altLang="zh-TW">
+                <a:latin typeface="Arial" panose="020B0604020202020204" pitchFamily="34" charset="0"/>
+                <a:cs typeface="Arial" panose="020B0604020202020204" pitchFamily="34" charset="0"/>
+              </a:rPr>
+              <a:t>.</a:t>
+            </a:r>
+            <a:endParaRPr lang="en-US" altLang="zh-TW">
+              <a:solidFill>
+                <a:srgbClr val="000000"/>
+              </a:solidFill>
+              <a:latin typeface="Arial" panose="020B0604020202020204" pitchFamily="34" charset="0"/>
+              <a:cs typeface="Arial" panose="020B0604020202020204" pitchFamily="34" charset="0"/>
+            </a:endParaRPr>
+          </a:p>
+          <a:p>
+            <a:pPr marL="742950" lvl="1" indent="-285750">
+              <a:buFont typeface="Arial" panose="020B0604020202020204" pitchFamily="34" charset="0"/>
+              <a:buChar char="•"/>
+            </a:pPr>
+            <a:r>
+              <a:rPr lang="en-US" altLang="zh-TW">
+                <a:solidFill>
+                  <a:srgbClr val="000000"/>
+                </a:solidFill>
+              </a:rPr>
+              <a:t>value: </a:t>
+            </a:r>
+            <a:r>
+              <a:rPr lang="zh-TW" altLang="en-US">
+                <a:solidFill>
+                  <a:srgbClr val="000000"/>
+                </a:solidFill>
+              </a:rPr>
+              <a:t>初始值 </a:t>
+            </a:r>
+            <a:r>
+              <a:rPr lang="zh-TW" altLang="zh-TW">
+                <a:latin typeface="Arial" panose="020B0604020202020204" pitchFamily="34" charset="0"/>
+                <a:cs typeface="Arial" panose="020B0604020202020204" pitchFamily="34" charset="0"/>
+              </a:rPr>
+              <a:t>Initial value.</a:t>
+            </a:r>
+            <a:endParaRPr lang="en-US" altLang="zh-TW">
+              <a:solidFill>
+                <a:srgbClr val="000000"/>
+              </a:solidFill>
+              <a:latin typeface="Arial" panose="020B0604020202020204" pitchFamily="34" charset="0"/>
+              <a:cs typeface="Arial" panose="020B0604020202020204" pitchFamily="34" charset="0"/>
+            </a:endParaRPr>
+          </a:p>
+        </p:txBody>
+      </p:sp>
+      <p:sp>
+        <p:nvSpPr>
+          <p:cNvPr id="7" name="文字方塊 6">
+            <a:extLst>
+              <a:ext uri="{FF2B5EF4-FFF2-40B4-BE49-F238E27FC236}">
+                <a16:creationId xmlns:a16="http://schemas.microsoft.com/office/drawing/2014/main" id="{CF4322A7-B279-FCCC-C1F9-5D56AC5B0709}"/>
+              </a:ext>
+            </a:extLst>
+          </p:cNvPr>
+          <p:cNvSpPr txBox="1"/>
+          <p:nvPr/>
+        </p:nvSpPr>
+        <p:spPr>
+          <a:xfrm>
+            <a:off x="521109" y="4220048"/>
+            <a:ext cx="10736825" cy="369332"/>
+          </a:xfrm>
+          <a:prstGeom prst="rect">
+            <a:avLst/>
+          </a:prstGeom>
+          <a:noFill/>
+        </p:spPr>
+        <p:txBody>
+          <a:bodyPr wrap="square">
+            <a:spAutoFit/>
+          </a:bodyPr>
+          <a:lstStyle/>
+          <a:p>
+            <a:r>
+              <a:rPr lang="en-US" altLang="zh-TW">
+                <a:solidFill>
+                  <a:srgbClr val="FF0000"/>
+                </a:solidFill>
+              </a:rPr>
+              <a:t>selectizeInput</a:t>
+            </a:r>
+            <a:r>
+              <a:rPr lang="zh-TW" altLang="zh-TW"/>
+              <a:t>(</a:t>
+            </a:r>
+            <a:r>
+              <a:rPr lang="en-US" altLang="zh-TW"/>
+              <a:t>inputId = </a:t>
+            </a:r>
+            <a:r>
+              <a:rPr lang="zh-TW" altLang="zh-TW"/>
+              <a:t>"name", </a:t>
+            </a:r>
+            <a:r>
+              <a:rPr lang="en-US" altLang="zh-TW"/>
+              <a:t>label = </a:t>
+            </a:r>
+            <a:r>
+              <a:rPr lang="zh-TW" altLang="zh-TW"/>
+              <a:t>"Your full name", value = "John Smith")</a:t>
+            </a:r>
+            <a:endParaRPr lang="zh-TW" altLang="en-US"/>
+          </a:p>
+        </p:txBody>
+      </p:sp>
+      <p:pic>
+        <p:nvPicPr>
+          <p:cNvPr id="9" name="圖片 8">
+            <a:extLst>
+              <a:ext uri="{FF2B5EF4-FFF2-40B4-BE49-F238E27FC236}">
+                <a16:creationId xmlns:a16="http://schemas.microsoft.com/office/drawing/2014/main" id="{A9AA0EA3-8DC4-A93C-F1E7-4046AED82B08}"/>
+              </a:ext>
+            </a:extLst>
+          </p:cNvPr>
+          <p:cNvPicPr>
+            <a:picLocks noChangeAspect="1"/>
+          </p:cNvPicPr>
+          <p:nvPr/>
+        </p:nvPicPr>
+        <p:blipFill>
+          <a:blip r:embed="rId2"/>
+          <a:stretch>
+            <a:fillRect/>
+          </a:stretch>
+        </p:blipFill>
+        <p:spPr>
+          <a:xfrm>
+            <a:off x="3992697" y="4855602"/>
+            <a:ext cx="4206605" cy="1089754"/>
+          </a:xfrm>
+          <a:prstGeom prst="rect">
+            <a:avLst/>
+          </a:prstGeom>
+        </p:spPr>
+      </p:pic>
+      <p:sp>
+        <p:nvSpPr>
+          <p:cNvPr id="19" name="文字方塊 18">
+            <a:extLst>
+              <a:ext uri="{FF2B5EF4-FFF2-40B4-BE49-F238E27FC236}">
                 <a16:creationId xmlns:a16="http://schemas.microsoft.com/office/drawing/2014/main" id="{78B2264A-3973-697F-7A51-AB8FB2A27373}"/>
               </a:ext>
             </a:extLst>
@@ -3983,7 +4669,7 @@
 </p:sld>
 </file>
 
-<file path=ppt/slides/slide11.xml><?xml version="1.0" encoding="utf-8"?>
+<file path=ppt/slides/slide13.xml><?xml version="1.0" encoding="utf-8"?>
 <p:sld xmlns:a="http://schemas.openxmlformats.org/drawingml/2006/main" xmlns:r="http://schemas.openxmlformats.org/officeDocument/2006/relationships" xmlns:p="http://schemas.openxmlformats.org/presentationml/2006/main">
   <p:cSld>
     <p:spTree>
@@ -4325,7 +5011,7 @@
 </p:sld>
 </file>
 
-<file path=ppt/slides/slide12.xml><?xml version="1.0" encoding="utf-8"?>
+<file path=ppt/slides/slide14.xml><?xml version="1.0" encoding="utf-8"?>
 <p:sld xmlns:a="http://schemas.openxmlformats.org/drawingml/2006/main" xmlns:r="http://schemas.openxmlformats.org/officeDocument/2006/relationships" xmlns:p="http://schemas.openxmlformats.org/presentationml/2006/main">
   <p:cSld>
     <p:spTree>
@@ -4684,7 +5370,7 @@
 </p:sld>
 </file>
 
-<file path=ppt/slides/slide13.xml><?xml version="1.0" encoding="utf-8"?>
+<file path=ppt/slides/slide15.xml><?xml version="1.0" encoding="utf-8"?>
 <p:sld xmlns:a="http://schemas.openxmlformats.org/drawingml/2006/main" xmlns:r="http://schemas.openxmlformats.org/officeDocument/2006/relationships" xmlns:p="http://schemas.openxmlformats.org/presentationml/2006/main">
   <p:cSld>
     <p:spTree>
@@ -4733,6 +5419,102 @@
       </p:grpSpPr>
       <p:sp>
         <p:nvSpPr>
+          <p:cNvPr id="2" name="矩形: 圓角 1">
+            <a:extLst>
+              <a:ext uri="{FF2B5EF4-FFF2-40B4-BE49-F238E27FC236}">
+                <a16:creationId xmlns:a16="http://schemas.microsoft.com/office/drawing/2014/main" id="{6C14FEEA-31FA-82C5-4D88-40D884048989}"/>
+              </a:ext>
+            </a:extLst>
+          </p:cNvPr>
+          <p:cNvSpPr/>
+          <p:nvPr/>
+        </p:nvSpPr>
+        <p:spPr>
+          <a:xfrm>
+            <a:off x="186813" y="186813"/>
+            <a:ext cx="3382297" cy="6341806"/>
+          </a:xfrm>
+          <a:prstGeom prst="roundRect">
+            <a:avLst/>
+          </a:prstGeom>
+          <a:solidFill>
+            <a:schemeClr val="bg2"/>
+          </a:solidFill>
+          <a:ln>
+            <a:solidFill>
+              <a:schemeClr val="bg2"/>
+            </a:solidFill>
+          </a:ln>
+        </p:spPr>
+        <p:style>
+          <a:lnRef idx="2">
+            <a:schemeClr val="accent1">
+              <a:shade val="15000"/>
+            </a:schemeClr>
+          </a:lnRef>
+          <a:fillRef idx="1">
+            <a:schemeClr val="accent1"/>
+          </a:fillRef>
+          <a:effectRef idx="0">
+            <a:schemeClr val="accent1"/>
+          </a:effectRef>
+          <a:fontRef idx="minor">
+            <a:schemeClr val="lt1"/>
+          </a:fontRef>
+        </p:style>
+        <p:txBody>
+          <a:bodyPr rtlCol="0" anchor="ctr"/>
+          <a:lstStyle/>
+          <a:p>
+            <a:pPr algn="ctr"/>
+            <a:r>
+              <a:rPr lang="en-US" altLang="zh-TW">
+                <a:solidFill>
+                  <a:schemeClr val="tx1"/>
+                </a:solidFill>
+              </a:rPr>
+              <a:t>Input Area</a:t>
+            </a:r>
+            <a:endParaRPr lang="zh-TW" altLang="en-US">
+              <a:solidFill>
+                <a:schemeClr val="tx1"/>
+              </a:solidFill>
+            </a:endParaRPr>
+          </a:p>
+        </p:txBody>
+      </p:sp>
+    </p:spTree>
+    <p:extLst>
+      <p:ext uri="{BB962C8B-B14F-4D97-AF65-F5344CB8AC3E}">
+        <p14:creationId xmlns:p14="http://schemas.microsoft.com/office/powerpoint/2010/main" val="174323355"/>
+      </p:ext>
+    </p:extLst>
+  </p:cSld>
+  <p:clrMapOvr>
+    <a:masterClrMapping/>
+  </p:clrMapOvr>
+</p:sld>
+</file>
+
+<file path=ppt/slides/slide3.xml><?xml version="1.0" encoding="utf-8"?>
+<p:sld xmlns:a="http://schemas.openxmlformats.org/drawingml/2006/main" xmlns:r="http://schemas.openxmlformats.org/officeDocument/2006/relationships" xmlns:p="http://schemas.openxmlformats.org/presentationml/2006/main">
+  <p:cSld>
+    <p:spTree>
+      <p:nvGrpSpPr>
+        <p:cNvPr id="1" name=""/>
+        <p:cNvGrpSpPr/>
+        <p:nvPr/>
+      </p:nvGrpSpPr>
+      <p:grpSpPr>
+        <a:xfrm>
+          <a:off x="0" y="0"/>
+          <a:ext cx="0" cy="0"/>
+          <a:chOff x="0" y="0"/>
+          <a:chExt cx="0" cy="0"/>
+        </a:xfrm>
+      </p:grpSpPr>
+      <p:sp>
+        <p:nvSpPr>
           <p:cNvPr id="2" name="文字方塊 1">
             <a:extLst>
               <a:ext uri="{FF2B5EF4-FFF2-40B4-BE49-F238E27FC236}">
@@ -4923,7 +5705,7 @@
 </p:sld>
 </file>
 
-<file path=ppt/slides/slide3.xml><?xml version="1.0" encoding="utf-8"?>
+<file path=ppt/slides/slide4.xml><?xml version="1.0" encoding="utf-8"?>
 <p:sld xmlns:a="http://schemas.openxmlformats.org/drawingml/2006/main" xmlns:r="http://schemas.openxmlformats.org/officeDocument/2006/relationships" xmlns:p="http://schemas.openxmlformats.org/presentationml/2006/main">
   <p:cSld>
     <p:spTree>
@@ -5085,7 +5867,7 @@
 </p:sld>
 </file>
 
-<file path=ppt/slides/slide4.xml><?xml version="1.0" encoding="utf-8"?>
+<file path=ppt/slides/slide5.xml><?xml version="1.0" encoding="utf-8"?>
 <p:sld xmlns:a="http://schemas.openxmlformats.org/drawingml/2006/main" xmlns:r="http://schemas.openxmlformats.org/officeDocument/2006/relationships" xmlns:p="http://schemas.openxmlformats.org/presentationml/2006/main">
   <p:cSld>
     <p:spTree>
@@ -6452,7 +7234,236 @@
 </p:sld>
 </file>
 
-<file path=ppt/slides/slide5.xml><?xml version="1.0" encoding="utf-8"?>
+<file path=ppt/slides/slide6.xml><?xml version="1.0" encoding="utf-8"?>
+<p:sld xmlns:a="http://schemas.openxmlformats.org/drawingml/2006/main" xmlns:r="http://schemas.openxmlformats.org/officeDocument/2006/relationships" xmlns:p="http://schemas.openxmlformats.org/presentationml/2006/main">
+  <p:cSld>
+    <p:spTree>
+      <p:nvGrpSpPr>
+        <p:cNvPr id="1" name="">
+          <a:extLst>
+            <a:ext uri="{FF2B5EF4-FFF2-40B4-BE49-F238E27FC236}">
+              <a16:creationId xmlns:a16="http://schemas.microsoft.com/office/drawing/2014/main" id="{7AB430BB-C506-64CA-D162-1E350C31BB02}"/>
+            </a:ext>
+          </a:extLst>
+        </p:cNvPr>
+        <p:cNvGrpSpPr/>
+        <p:nvPr/>
+      </p:nvGrpSpPr>
+      <p:grpSpPr>
+        <a:xfrm>
+          <a:off x="0" y="0"/>
+          <a:ext cx="0" cy="0"/>
+          <a:chOff x="0" y="0"/>
+          <a:chExt cx="0" cy="0"/>
+        </a:xfrm>
+      </p:grpSpPr>
+      <p:sp>
+        <p:nvSpPr>
+          <p:cNvPr id="3" name="文字方塊 2">
+            <a:extLst>
+              <a:ext uri="{FF2B5EF4-FFF2-40B4-BE49-F238E27FC236}">
+                <a16:creationId xmlns:a16="http://schemas.microsoft.com/office/drawing/2014/main" id="{73F6CEC2-B7E7-794A-FE53-158F13FA1C8D}"/>
+              </a:ext>
+            </a:extLst>
+          </p:cNvPr>
+          <p:cNvSpPr txBox="1"/>
+          <p:nvPr/>
+        </p:nvSpPr>
+        <p:spPr>
+          <a:xfrm>
+            <a:off x="196649" y="278749"/>
+            <a:ext cx="11867532" cy="369332"/>
+          </a:xfrm>
+          <a:prstGeom prst="rect">
+            <a:avLst/>
+          </a:prstGeom>
+          <a:noFill/>
+        </p:spPr>
+        <p:txBody>
+          <a:bodyPr wrap="square">
+            <a:spAutoFit/>
+          </a:bodyPr>
+          <a:lstStyle/>
+          <a:p>
+            <a:pPr marL="285750" indent="-285750">
+              <a:buFont typeface="Arial" panose="020B0604020202020204" pitchFamily="34" charset="0"/>
+              <a:buChar char="•"/>
+            </a:pPr>
+            <a:r>
+              <a:rPr lang="en-US" altLang="zh-TW">
+                <a:solidFill>
+                  <a:srgbClr val="FF0000"/>
+                </a:solidFill>
+              </a:rPr>
+              <a:t>uiOutp</a:t>
+            </a:r>
+            <a:r>
+              <a:rPr lang="zh-TW" altLang="zh-TW" i="0">
+                <a:solidFill>
+                  <a:srgbClr val="FF0000"/>
+                </a:solidFill>
+                <a:effectLst/>
+              </a:rPr>
+              <a:t>ut</a:t>
+            </a:r>
+            <a:r>
+              <a:rPr lang="en-US" altLang="zh-TW" i="0">
+                <a:solidFill>
+                  <a:srgbClr val="000000"/>
+                </a:solidFill>
+                <a:effectLst/>
+              </a:rPr>
+              <a:t>:</a:t>
+            </a:r>
+            <a:endParaRPr lang="zh-TW" altLang="en-US">
+              <a:latin typeface="Arial" panose="020B0604020202020204" pitchFamily="34" charset="0"/>
+              <a:cs typeface="Arial" panose="020B0604020202020204" pitchFamily="34" charset="0"/>
+            </a:endParaRPr>
+          </a:p>
+        </p:txBody>
+      </p:sp>
+      <p:sp>
+        <p:nvSpPr>
+          <p:cNvPr id="7" name="文字方塊 6">
+            <a:extLst>
+              <a:ext uri="{FF2B5EF4-FFF2-40B4-BE49-F238E27FC236}">
+                <a16:creationId xmlns:a16="http://schemas.microsoft.com/office/drawing/2014/main" id="{010CEBEB-C2D2-828A-3129-285AC23A65F1}"/>
+              </a:ext>
+            </a:extLst>
+          </p:cNvPr>
+          <p:cNvSpPr txBox="1"/>
+          <p:nvPr/>
+        </p:nvSpPr>
+        <p:spPr>
+          <a:xfrm>
+            <a:off x="521110" y="4220048"/>
+            <a:ext cx="9586452" cy="369332"/>
+          </a:xfrm>
+          <a:prstGeom prst="rect">
+            <a:avLst/>
+          </a:prstGeom>
+          <a:noFill/>
+        </p:spPr>
+        <p:txBody>
+          <a:bodyPr wrap="square">
+            <a:spAutoFit/>
+          </a:bodyPr>
+          <a:lstStyle/>
+          <a:p>
+            <a:r>
+              <a:rPr lang="en-US" altLang="zh-TW"/>
+              <a:t>textInput</a:t>
+            </a:r>
+            <a:r>
+              <a:rPr lang="zh-TW" altLang="zh-TW"/>
+              <a:t>(</a:t>
+            </a:r>
+            <a:r>
+              <a:rPr lang="en-US" altLang="zh-TW"/>
+              <a:t>inputId = </a:t>
+            </a:r>
+            <a:r>
+              <a:rPr lang="zh-TW" altLang="zh-TW"/>
+              <a:t>"name", </a:t>
+            </a:r>
+            <a:r>
+              <a:rPr lang="en-US" altLang="zh-TW"/>
+              <a:t>label = </a:t>
+            </a:r>
+            <a:r>
+              <a:rPr lang="zh-TW" altLang="zh-TW"/>
+              <a:t>"Your full name", value = "John Smith")</a:t>
+            </a:r>
+            <a:endParaRPr lang="zh-TW" altLang="en-US"/>
+          </a:p>
+        </p:txBody>
+      </p:sp>
+      <p:pic>
+        <p:nvPicPr>
+          <p:cNvPr id="9" name="圖片 8">
+            <a:extLst>
+              <a:ext uri="{FF2B5EF4-FFF2-40B4-BE49-F238E27FC236}">
+                <a16:creationId xmlns:a16="http://schemas.microsoft.com/office/drawing/2014/main" id="{2759C352-5B17-3C31-3BD6-77FAA94C57C0}"/>
+              </a:ext>
+            </a:extLst>
+          </p:cNvPr>
+          <p:cNvPicPr>
+            <a:picLocks noChangeAspect="1"/>
+          </p:cNvPicPr>
+          <p:nvPr/>
+        </p:nvPicPr>
+        <p:blipFill>
+          <a:blip r:embed="rId2"/>
+          <a:stretch>
+            <a:fillRect/>
+          </a:stretch>
+        </p:blipFill>
+        <p:spPr>
+          <a:xfrm>
+            <a:off x="3992697" y="4855602"/>
+            <a:ext cx="4206605" cy="1089754"/>
+          </a:xfrm>
+          <a:prstGeom prst="rect">
+            <a:avLst/>
+          </a:prstGeom>
+        </p:spPr>
+      </p:pic>
+      <p:sp>
+        <p:nvSpPr>
+          <p:cNvPr id="19" name="文字方塊 18">
+            <a:extLst>
+              <a:ext uri="{FF2B5EF4-FFF2-40B4-BE49-F238E27FC236}">
+                <a16:creationId xmlns:a16="http://schemas.microsoft.com/office/drawing/2014/main" id="{862FA2BE-D0C9-D744-6781-4AF08A179D90}"/>
+              </a:ext>
+            </a:extLst>
+          </p:cNvPr>
+          <p:cNvSpPr txBox="1"/>
+          <p:nvPr/>
+        </p:nvSpPr>
+        <p:spPr>
+          <a:xfrm>
+            <a:off x="521110" y="3429000"/>
+            <a:ext cx="3097161" cy="461665"/>
+          </a:xfrm>
+          <a:prstGeom prst="rect">
+            <a:avLst/>
+          </a:prstGeom>
+          <a:noFill/>
+        </p:spPr>
+        <p:txBody>
+          <a:bodyPr wrap="square" rtlCol="0">
+            <a:spAutoFit/>
+          </a:bodyPr>
+          <a:lstStyle/>
+          <a:p>
+            <a:r>
+              <a:rPr lang="en-US" altLang="zh-TW" sz="2400">
+                <a:latin typeface="Arial" panose="020B0604020202020204" pitchFamily="34" charset="0"/>
+                <a:cs typeface="Arial" panose="020B0604020202020204" pitchFamily="34" charset="0"/>
+              </a:rPr>
+              <a:t>Example: </a:t>
+            </a:r>
+            <a:endParaRPr lang="zh-TW" altLang="en-US" sz="2400">
+              <a:latin typeface="Arial" panose="020B0604020202020204" pitchFamily="34" charset="0"/>
+              <a:cs typeface="Arial" panose="020B0604020202020204" pitchFamily="34" charset="0"/>
+            </a:endParaRPr>
+          </a:p>
+        </p:txBody>
+      </p:sp>
+    </p:spTree>
+    <p:extLst>
+      <p:ext uri="{BB962C8B-B14F-4D97-AF65-F5344CB8AC3E}">
+        <p14:creationId xmlns:p14="http://schemas.microsoft.com/office/powerpoint/2010/main" val="2657147157"/>
+      </p:ext>
+    </p:extLst>
+  </p:cSld>
+  <p:clrMapOvr>
+    <a:masterClrMapping/>
+  </p:clrMapOvr>
+</p:sld>
+</file>
+
+<file path=ppt/slides/slide7.xml><?xml version="1.0" encoding="utf-8"?>
 <p:sld xmlns:a="http://schemas.openxmlformats.org/drawingml/2006/main" xmlns:r="http://schemas.openxmlformats.org/officeDocument/2006/relationships" xmlns:p="http://schemas.openxmlformats.org/presentationml/2006/main">
   <p:cSld>
     <p:spTree>
@@ -7031,7 +8042,7 @@
 </p:sld>
 </file>
 
-<file path=ppt/slides/slide6.xml><?xml version="1.0" encoding="utf-8"?>
+<file path=ppt/slides/slide8.xml><?xml version="1.0" encoding="utf-8"?>
 <p:sld xmlns:a="http://schemas.openxmlformats.org/drawingml/2006/main" xmlns:r="http://schemas.openxmlformats.org/officeDocument/2006/relationships" xmlns:p="http://schemas.openxmlformats.org/presentationml/2006/main">
   <p:cSld>
     <p:spTree>
@@ -7372,7 +8383,7 @@
 </p:sld>
 </file>
 
-<file path=ppt/slides/slide7.xml><?xml version="1.0" encoding="utf-8"?>
+<file path=ppt/slides/slide9.xml><?xml version="1.0" encoding="utf-8"?>
 <p:sld xmlns:a="http://schemas.openxmlformats.org/drawingml/2006/main" xmlns:r="http://schemas.openxmlformats.org/officeDocument/2006/relationships" xmlns:p="http://schemas.openxmlformats.org/presentationml/2006/main">
   <p:cSld>
     <p:spTree>
@@ -7705,690 +8716,6 @@
     <p:extLst>
       <p:ext uri="{BB962C8B-B14F-4D97-AF65-F5344CB8AC3E}">
         <p14:creationId xmlns:p14="http://schemas.microsoft.com/office/powerpoint/2010/main" val="4168882066"/>
-      </p:ext>
-    </p:extLst>
-  </p:cSld>
-  <p:clrMapOvr>
-    <a:masterClrMapping/>
-  </p:clrMapOvr>
-</p:sld>
-</file>
-
-<file path=ppt/slides/slide8.xml><?xml version="1.0" encoding="utf-8"?>
-<p:sld xmlns:a="http://schemas.openxmlformats.org/drawingml/2006/main" xmlns:r="http://schemas.openxmlformats.org/officeDocument/2006/relationships" xmlns:p="http://schemas.openxmlformats.org/presentationml/2006/main">
-  <p:cSld>
-    <p:spTree>
-      <p:nvGrpSpPr>
-        <p:cNvPr id="1" name="">
-          <a:extLst>
-            <a:ext uri="{FF2B5EF4-FFF2-40B4-BE49-F238E27FC236}">
-              <a16:creationId xmlns:a16="http://schemas.microsoft.com/office/drawing/2014/main" id="{EFEBAEEC-72AC-351A-421B-C1910F2A8EC4}"/>
-            </a:ext>
-          </a:extLst>
-        </p:cNvPr>
-        <p:cNvGrpSpPr/>
-        <p:nvPr/>
-      </p:nvGrpSpPr>
-      <p:grpSpPr>
-        <a:xfrm>
-          <a:off x="0" y="0"/>
-          <a:ext cx="0" cy="0"/>
-          <a:chOff x="0" y="0"/>
-          <a:chExt cx="0" cy="0"/>
-        </a:xfrm>
-      </p:grpSpPr>
-      <p:sp>
-        <p:nvSpPr>
-          <p:cNvPr id="3" name="文字方塊 2">
-            <a:extLst>
-              <a:ext uri="{FF2B5EF4-FFF2-40B4-BE49-F238E27FC236}">
-                <a16:creationId xmlns:a16="http://schemas.microsoft.com/office/drawing/2014/main" id="{FBA40D14-B996-9EDB-E4C2-83528485C334}"/>
-              </a:ext>
-            </a:extLst>
-          </p:cNvPr>
-          <p:cNvSpPr txBox="1"/>
-          <p:nvPr/>
-        </p:nvSpPr>
-        <p:spPr>
-          <a:xfrm>
-            <a:off x="196649" y="278749"/>
-            <a:ext cx="11867532" cy="1200329"/>
-          </a:xfrm>
-          <a:prstGeom prst="rect">
-            <a:avLst/>
-          </a:prstGeom>
-          <a:noFill/>
-        </p:spPr>
-        <p:txBody>
-          <a:bodyPr wrap="square">
-            <a:spAutoFit/>
-          </a:bodyPr>
-          <a:lstStyle/>
-          <a:p>
-            <a:pPr marL="285750" indent="-285750">
-              <a:buFont typeface="Arial" panose="020B0604020202020204" pitchFamily="34" charset="0"/>
-              <a:buChar char="•"/>
-            </a:pPr>
-            <a:r>
-              <a:rPr lang="en-US" altLang="zh-TW">
-                <a:solidFill>
-                  <a:srgbClr val="FF0000"/>
-                </a:solidFill>
-              </a:rPr>
-              <a:t>fileInput</a:t>
-            </a:r>
-            <a:r>
-              <a:rPr lang="en-US" altLang="zh-TW" i="0">
-                <a:solidFill>
-                  <a:srgbClr val="000000"/>
-                </a:solidFill>
-                <a:effectLst/>
-              </a:rPr>
-              <a:t>:</a:t>
-            </a:r>
-            <a:r>
-              <a:rPr lang="zh-TW" altLang="en-US" i="0">
-                <a:solidFill>
-                  <a:srgbClr val="000000"/>
-                </a:solidFill>
-                <a:effectLst/>
-              </a:rPr>
-              <a:t> </a:t>
-            </a:r>
-            <a:endParaRPr lang="en-US" altLang="zh-TW">
-              <a:solidFill>
-                <a:srgbClr val="000000"/>
-              </a:solidFill>
-              <a:latin typeface="Arial" panose="020B0604020202020204" pitchFamily="34" charset="0"/>
-            </a:endParaRPr>
-          </a:p>
-          <a:p>
-            <a:pPr marL="742950" lvl="1" indent="-285750">
-              <a:buFont typeface="Arial" panose="020B0604020202020204" pitchFamily="34" charset="0"/>
-              <a:buChar char="•"/>
-            </a:pPr>
-            <a:r>
-              <a:rPr lang="en-US" altLang="zh-TW">
-                <a:solidFill>
-                  <a:srgbClr val="000000"/>
-                </a:solidFill>
-              </a:rPr>
-              <a:t>inputId: </a:t>
-            </a:r>
-            <a:r>
-              <a:rPr lang="zh-TW" altLang="zh-TW">
-                <a:latin typeface="Arial" panose="020B0604020202020204" pitchFamily="34" charset="0"/>
-                <a:cs typeface="Arial" panose="020B0604020202020204" pitchFamily="34" charset="0"/>
-              </a:rPr>
-              <a:t>The input slot that will be used to access the value.</a:t>
-            </a:r>
-            <a:endParaRPr lang="en-US" altLang="zh-TW">
-              <a:solidFill>
-                <a:srgbClr val="000000"/>
-              </a:solidFill>
-              <a:latin typeface="Arial" panose="020B0604020202020204" pitchFamily="34" charset="0"/>
-              <a:cs typeface="Arial" panose="020B0604020202020204" pitchFamily="34" charset="0"/>
-            </a:endParaRPr>
-          </a:p>
-          <a:p>
-            <a:pPr marL="742950" lvl="1" indent="-285750">
-              <a:buFont typeface="Arial" panose="020B0604020202020204" pitchFamily="34" charset="0"/>
-              <a:buChar char="•"/>
-            </a:pPr>
-            <a:r>
-              <a:rPr lang="en-US" altLang="zh-TW">
-                <a:solidFill>
-                  <a:srgbClr val="000000"/>
-                </a:solidFill>
-              </a:rPr>
-              <a:t>label: </a:t>
-            </a:r>
-            <a:r>
-              <a:rPr lang="zh-TW" altLang="en-US">
-                <a:solidFill>
-                  <a:srgbClr val="000000"/>
-                </a:solidFill>
-              </a:rPr>
-              <a:t>標題 </a:t>
-            </a:r>
-            <a:r>
-              <a:rPr lang="zh-TW" altLang="zh-TW">
-                <a:latin typeface="Arial" panose="020B0604020202020204" pitchFamily="34" charset="0"/>
-                <a:cs typeface="Arial" panose="020B0604020202020204" pitchFamily="34" charset="0"/>
-              </a:rPr>
-              <a:t>Display label for the control</a:t>
-            </a:r>
-            <a:r>
-              <a:rPr lang="en-US" altLang="zh-TW">
-                <a:latin typeface="Arial" panose="020B0604020202020204" pitchFamily="34" charset="0"/>
-                <a:cs typeface="Arial" panose="020B0604020202020204" pitchFamily="34" charset="0"/>
-              </a:rPr>
-              <a:t>.</a:t>
-            </a:r>
-            <a:endParaRPr lang="en-US" altLang="zh-TW">
-              <a:solidFill>
-                <a:srgbClr val="000000"/>
-              </a:solidFill>
-              <a:latin typeface="Arial" panose="020B0604020202020204" pitchFamily="34" charset="0"/>
-              <a:cs typeface="Arial" panose="020B0604020202020204" pitchFamily="34" charset="0"/>
-            </a:endParaRPr>
-          </a:p>
-          <a:p>
-            <a:pPr marL="742950" lvl="1" indent="-285750">
-              <a:buFont typeface="Arial" panose="020B0604020202020204" pitchFamily="34" charset="0"/>
-              <a:buChar char="•"/>
-            </a:pPr>
-            <a:r>
-              <a:rPr lang="en-US" altLang="zh-TW">
-                <a:solidFill>
-                  <a:srgbClr val="000000"/>
-                </a:solidFill>
-              </a:rPr>
-              <a:t>value: </a:t>
-            </a:r>
-            <a:r>
-              <a:rPr lang="zh-TW" altLang="en-US">
-                <a:solidFill>
-                  <a:srgbClr val="000000"/>
-                </a:solidFill>
-              </a:rPr>
-              <a:t>初始值 </a:t>
-            </a:r>
-            <a:r>
-              <a:rPr lang="zh-TW" altLang="zh-TW">
-                <a:latin typeface="Arial" panose="020B0604020202020204" pitchFamily="34" charset="0"/>
-                <a:cs typeface="Arial" panose="020B0604020202020204" pitchFamily="34" charset="0"/>
-              </a:rPr>
-              <a:t>Initial value.</a:t>
-            </a:r>
-            <a:endParaRPr lang="en-US" altLang="zh-TW">
-              <a:solidFill>
-                <a:srgbClr val="000000"/>
-              </a:solidFill>
-              <a:latin typeface="Arial" panose="020B0604020202020204" pitchFamily="34" charset="0"/>
-              <a:cs typeface="Arial" panose="020B0604020202020204" pitchFamily="34" charset="0"/>
-            </a:endParaRPr>
-          </a:p>
-        </p:txBody>
-      </p:sp>
-      <p:sp>
-        <p:nvSpPr>
-          <p:cNvPr id="7" name="文字方塊 6">
-            <a:extLst>
-              <a:ext uri="{FF2B5EF4-FFF2-40B4-BE49-F238E27FC236}">
-                <a16:creationId xmlns:a16="http://schemas.microsoft.com/office/drawing/2014/main" id="{921EB90A-1652-8947-21EA-EFB2AF8E7B36}"/>
-              </a:ext>
-            </a:extLst>
-          </p:cNvPr>
-          <p:cNvSpPr txBox="1"/>
-          <p:nvPr/>
-        </p:nvSpPr>
-        <p:spPr>
-          <a:xfrm>
-            <a:off x="521109" y="4220048"/>
-            <a:ext cx="10736825" cy="369332"/>
-          </a:xfrm>
-          <a:prstGeom prst="rect">
-            <a:avLst/>
-          </a:prstGeom>
-          <a:noFill/>
-        </p:spPr>
-        <p:txBody>
-          <a:bodyPr wrap="square">
-            <a:spAutoFit/>
-          </a:bodyPr>
-          <a:lstStyle/>
-          <a:p>
-            <a:r>
-              <a:rPr lang="en-US" altLang="zh-TW">
-                <a:solidFill>
-                  <a:srgbClr val="FF0000"/>
-                </a:solidFill>
-              </a:rPr>
-              <a:t>fileInput</a:t>
-            </a:r>
-            <a:r>
-              <a:rPr lang="zh-TW" altLang="zh-TW"/>
-              <a:t>(</a:t>
-            </a:r>
-            <a:r>
-              <a:rPr lang="en-US" altLang="zh-TW"/>
-              <a:t>inputId = </a:t>
-            </a:r>
-            <a:r>
-              <a:rPr lang="zh-TW" altLang="zh-TW"/>
-              <a:t>"name", </a:t>
-            </a:r>
-            <a:r>
-              <a:rPr lang="en-US" altLang="zh-TW"/>
-              <a:t>label = </a:t>
-            </a:r>
-            <a:r>
-              <a:rPr lang="zh-TW" altLang="zh-TW"/>
-              <a:t>"Your full name", value = "John Smith")</a:t>
-            </a:r>
-            <a:endParaRPr lang="zh-TW" altLang="en-US"/>
-          </a:p>
-        </p:txBody>
-      </p:sp>
-      <p:pic>
-        <p:nvPicPr>
-          <p:cNvPr id="9" name="圖片 8">
-            <a:extLst>
-              <a:ext uri="{FF2B5EF4-FFF2-40B4-BE49-F238E27FC236}">
-                <a16:creationId xmlns:a16="http://schemas.microsoft.com/office/drawing/2014/main" id="{DEC1CDF0-2F7B-3998-CF8B-7152111791D9}"/>
-              </a:ext>
-            </a:extLst>
-          </p:cNvPr>
-          <p:cNvPicPr>
-            <a:picLocks noChangeAspect="1"/>
-          </p:cNvPicPr>
-          <p:nvPr/>
-        </p:nvPicPr>
-        <p:blipFill>
-          <a:blip r:embed="rId2"/>
-          <a:stretch>
-            <a:fillRect/>
-          </a:stretch>
-        </p:blipFill>
-        <p:spPr>
-          <a:xfrm>
-            <a:off x="3992697" y="4855602"/>
-            <a:ext cx="4206605" cy="1089754"/>
-          </a:xfrm>
-          <a:prstGeom prst="rect">
-            <a:avLst/>
-          </a:prstGeom>
-        </p:spPr>
-      </p:pic>
-      <p:sp>
-        <p:nvSpPr>
-          <p:cNvPr id="19" name="文字方塊 18">
-            <a:extLst>
-              <a:ext uri="{FF2B5EF4-FFF2-40B4-BE49-F238E27FC236}">
-                <a16:creationId xmlns:a16="http://schemas.microsoft.com/office/drawing/2014/main" id="{CE53DA03-D6B9-03A0-076C-55DA07FB3E87}"/>
-              </a:ext>
-            </a:extLst>
-          </p:cNvPr>
-          <p:cNvSpPr txBox="1"/>
-          <p:nvPr/>
-        </p:nvSpPr>
-        <p:spPr>
-          <a:xfrm>
-            <a:off x="521110" y="3429000"/>
-            <a:ext cx="3097161" cy="461665"/>
-          </a:xfrm>
-          <a:prstGeom prst="rect">
-            <a:avLst/>
-          </a:prstGeom>
-          <a:noFill/>
-        </p:spPr>
-        <p:txBody>
-          <a:bodyPr wrap="square" rtlCol="0">
-            <a:spAutoFit/>
-          </a:bodyPr>
-          <a:lstStyle/>
-          <a:p>
-            <a:r>
-              <a:rPr lang="en-US" altLang="zh-TW" sz="2400">
-                <a:latin typeface="Arial" panose="020B0604020202020204" pitchFamily="34" charset="0"/>
-                <a:cs typeface="Arial" panose="020B0604020202020204" pitchFamily="34" charset="0"/>
-              </a:rPr>
-              <a:t>Example: </a:t>
-            </a:r>
-            <a:endParaRPr lang="zh-TW" altLang="en-US" sz="2400">
-              <a:latin typeface="Arial" panose="020B0604020202020204" pitchFamily="34" charset="0"/>
-              <a:cs typeface="Arial" panose="020B0604020202020204" pitchFamily="34" charset="0"/>
-            </a:endParaRPr>
-          </a:p>
-        </p:txBody>
-      </p:sp>
-    </p:spTree>
-    <p:extLst>
-      <p:ext uri="{BB962C8B-B14F-4D97-AF65-F5344CB8AC3E}">
-        <p14:creationId xmlns:p14="http://schemas.microsoft.com/office/powerpoint/2010/main" val="1947664966"/>
-      </p:ext>
-    </p:extLst>
-  </p:cSld>
-  <p:clrMapOvr>
-    <a:masterClrMapping/>
-  </p:clrMapOvr>
-</p:sld>
-</file>
-
-<file path=ppt/slides/slide9.xml><?xml version="1.0" encoding="utf-8"?>
-<p:sld xmlns:a="http://schemas.openxmlformats.org/drawingml/2006/main" xmlns:r="http://schemas.openxmlformats.org/officeDocument/2006/relationships" xmlns:p="http://schemas.openxmlformats.org/presentationml/2006/main">
-  <p:cSld>
-    <p:spTree>
-      <p:nvGrpSpPr>
-        <p:cNvPr id="1" name="">
-          <a:extLst>
-            <a:ext uri="{FF2B5EF4-FFF2-40B4-BE49-F238E27FC236}">
-              <a16:creationId xmlns:a16="http://schemas.microsoft.com/office/drawing/2014/main" id="{D7191584-B73A-2264-60D2-9906AA8FEEE0}"/>
-            </a:ext>
-          </a:extLst>
-        </p:cNvPr>
-        <p:cNvGrpSpPr/>
-        <p:nvPr/>
-      </p:nvGrpSpPr>
-      <p:grpSpPr>
-        <a:xfrm>
-          <a:off x="0" y="0"/>
-          <a:ext cx="0" cy="0"/>
-          <a:chOff x="0" y="0"/>
-          <a:chExt cx="0" cy="0"/>
-        </a:xfrm>
-      </p:grpSpPr>
-      <p:sp>
-        <p:nvSpPr>
-          <p:cNvPr id="3" name="文字方塊 2">
-            <a:extLst>
-              <a:ext uri="{FF2B5EF4-FFF2-40B4-BE49-F238E27FC236}">
-                <a16:creationId xmlns:a16="http://schemas.microsoft.com/office/drawing/2014/main" id="{8E5C9E97-906A-531B-CCD4-8E7B313AA44C}"/>
-              </a:ext>
-            </a:extLst>
-          </p:cNvPr>
-          <p:cNvSpPr txBox="1"/>
-          <p:nvPr/>
-        </p:nvSpPr>
-        <p:spPr>
-          <a:xfrm>
-            <a:off x="196649" y="278749"/>
-            <a:ext cx="11867532" cy="1200329"/>
-          </a:xfrm>
-          <a:prstGeom prst="rect">
-            <a:avLst/>
-          </a:prstGeom>
-          <a:noFill/>
-        </p:spPr>
-        <p:txBody>
-          <a:bodyPr wrap="square">
-            <a:spAutoFit/>
-          </a:bodyPr>
-          <a:lstStyle/>
-          <a:p>
-            <a:pPr marL="285750" indent="-285750">
-              <a:buFont typeface="Arial" panose="020B0604020202020204" pitchFamily="34" charset="0"/>
-              <a:buChar char="•"/>
-            </a:pPr>
-            <a:r>
-              <a:rPr lang="en-US" altLang="zh-TW">
-                <a:solidFill>
-                  <a:srgbClr val="FF0000"/>
-                </a:solidFill>
-              </a:rPr>
-              <a:t>selectInput</a:t>
-            </a:r>
-            <a:r>
-              <a:rPr lang="en-US" altLang="zh-TW" i="0">
-                <a:solidFill>
-                  <a:srgbClr val="000000"/>
-                </a:solidFill>
-                <a:effectLst/>
-              </a:rPr>
-              <a:t>:</a:t>
-            </a:r>
-            <a:r>
-              <a:rPr lang="zh-TW" altLang="en-US" i="0">
-                <a:solidFill>
-                  <a:srgbClr val="000000"/>
-                </a:solidFill>
-                <a:effectLst/>
-              </a:rPr>
-              <a:t> </a:t>
-            </a:r>
-            <a:endParaRPr lang="en-US" altLang="zh-TW">
-              <a:solidFill>
-                <a:srgbClr val="000000"/>
-              </a:solidFill>
-              <a:latin typeface="Arial" panose="020B0604020202020204" pitchFamily="34" charset="0"/>
-            </a:endParaRPr>
-          </a:p>
-          <a:p>
-            <a:pPr marL="742950" lvl="1" indent="-285750">
-              <a:buFont typeface="Arial" panose="020B0604020202020204" pitchFamily="34" charset="0"/>
-              <a:buChar char="•"/>
-            </a:pPr>
-            <a:r>
-              <a:rPr lang="en-US" altLang="zh-TW">
-                <a:solidFill>
-                  <a:srgbClr val="000000"/>
-                </a:solidFill>
-              </a:rPr>
-              <a:t>inputId: </a:t>
-            </a:r>
-            <a:r>
-              <a:rPr lang="zh-TW" altLang="zh-TW">
-                <a:latin typeface="Arial" panose="020B0604020202020204" pitchFamily="34" charset="0"/>
-                <a:cs typeface="Arial" panose="020B0604020202020204" pitchFamily="34" charset="0"/>
-              </a:rPr>
-              <a:t>The input slot that will be used to access the value.</a:t>
-            </a:r>
-            <a:endParaRPr lang="en-US" altLang="zh-TW">
-              <a:solidFill>
-                <a:srgbClr val="000000"/>
-              </a:solidFill>
-              <a:latin typeface="Arial" panose="020B0604020202020204" pitchFamily="34" charset="0"/>
-              <a:cs typeface="Arial" panose="020B0604020202020204" pitchFamily="34" charset="0"/>
-            </a:endParaRPr>
-          </a:p>
-          <a:p>
-            <a:pPr marL="742950" lvl="1" indent="-285750">
-              <a:buFont typeface="Arial" panose="020B0604020202020204" pitchFamily="34" charset="0"/>
-              <a:buChar char="•"/>
-            </a:pPr>
-            <a:r>
-              <a:rPr lang="en-US" altLang="zh-TW">
-                <a:solidFill>
-                  <a:srgbClr val="000000"/>
-                </a:solidFill>
-              </a:rPr>
-              <a:t>label: </a:t>
-            </a:r>
-            <a:r>
-              <a:rPr lang="zh-TW" altLang="en-US">
-                <a:solidFill>
-                  <a:srgbClr val="000000"/>
-                </a:solidFill>
-              </a:rPr>
-              <a:t>標題 </a:t>
-            </a:r>
-            <a:r>
-              <a:rPr lang="zh-TW" altLang="zh-TW">
-                <a:latin typeface="Arial" panose="020B0604020202020204" pitchFamily="34" charset="0"/>
-                <a:cs typeface="Arial" panose="020B0604020202020204" pitchFamily="34" charset="0"/>
-              </a:rPr>
-              <a:t>Display label for the control</a:t>
-            </a:r>
-            <a:r>
-              <a:rPr lang="en-US" altLang="zh-TW">
-                <a:latin typeface="Arial" panose="020B0604020202020204" pitchFamily="34" charset="0"/>
-                <a:cs typeface="Arial" panose="020B0604020202020204" pitchFamily="34" charset="0"/>
-              </a:rPr>
-              <a:t>.</a:t>
-            </a:r>
-            <a:endParaRPr lang="en-US" altLang="zh-TW">
-              <a:solidFill>
-                <a:srgbClr val="000000"/>
-              </a:solidFill>
-              <a:latin typeface="Arial" panose="020B0604020202020204" pitchFamily="34" charset="0"/>
-              <a:cs typeface="Arial" panose="020B0604020202020204" pitchFamily="34" charset="0"/>
-            </a:endParaRPr>
-          </a:p>
-          <a:p>
-            <a:pPr marL="742950" lvl="1" indent="-285750">
-              <a:buFont typeface="Arial" panose="020B0604020202020204" pitchFamily="34" charset="0"/>
-              <a:buChar char="•"/>
-            </a:pPr>
-            <a:r>
-              <a:rPr lang="en-US" altLang="zh-TW">
-                <a:solidFill>
-                  <a:srgbClr val="000000"/>
-                </a:solidFill>
-              </a:rPr>
-              <a:t>value: </a:t>
-            </a:r>
-            <a:r>
-              <a:rPr lang="zh-TW" altLang="en-US">
-                <a:solidFill>
-                  <a:srgbClr val="000000"/>
-                </a:solidFill>
-              </a:rPr>
-              <a:t>初始值 </a:t>
-            </a:r>
-            <a:r>
-              <a:rPr lang="zh-TW" altLang="zh-TW">
-                <a:latin typeface="Arial" panose="020B0604020202020204" pitchFamily="34" charset="0"/>
-                <a:cs typeface="Arial" panose="020B0604020202020204" pitchFamily="34" charset="0"/>
-              </a:rPr>
-              <a:t>Initial value.</a:t>
-            </a:r>
-            <a:endParaRPr lang="en-US" altLang="zh-TW">
-              <a:solidFill>
-                <a:srgbClr val="000000"/>
-              </a:solidFill>
-              <a:latin typeface="Arial" panose="020B0604020202020204" pitchFamily="34" charset="0"/>
-              <a:cs typeface="Arial" panose="020B0604020202020204" pitchFamily="34" charset="0"/>
-            </a:endParaRPr>
-          </a:p>
-        </p:txBody>
-      </p:sp>
-      <p:sp>
-        <p:nvSpPr>
-          <p:cNvPr id="7" name="文字方塊 6">
-            <a:extLst>
-              <a:ext uri="{FF2B5EF4-FFF2-40B4-BE49-F238E27FC236}">
-                <a16:creationId xmlns:a16="http://schemas.microsoft.com/office/drawing/2014/main" id="{1BC3CB37-C489-F12B-25DB-08AAA4230C3F}"/>
-              </a:ext>
-            </a:extLst>
-          </p:cNvPr>
-          <p:cNvSpPr txBox="1"/>
-          <p:nvPr/>
-        </p:nvSpPr>
-        <p:spPr>
-          <a:xfrm>
-            <a:off x="521109" y="4220048"/>
-            <a:ext cx="10736825" cy="369332"/>
-          </a:xfrm>
-          <a:prstGeom prst="rect">
-            <a:avLst/>
-          </a:prstGeom>
-          <a:noFill/>
-        </p:spPr>
-        <p:txBody>
-          <a:bodyPr wrap="square">
-            <a:spAutoFit/>
-          </a:bodyPr>
-          <a:lstStyle/>
-          <a:p>
-            <a:r>
-              <a:rPr lang="en-US" altLang="zh-TW">
-                <a:solidFill>
-                  <a:srgbClr val="FF0000"/>
-                </a:solidFill>
-              </a:rPr>
-              <a:t>selectInput</a:t>
-            </a:r>
-            <a:r>
-              <a:rPr lang="zh-TW" altLang="zh-TW"/>
-              <a:t>(</a:t>
-            </a:r>
-            <a:r>
-              <a:rPr lang="en-US" altLang="zh-TW"/>
-              <a:t>inputId = </a:t>
-            </a:r>
-            <a:r>
-              <a:rPr lang="zh-TW" altLang="zh-TW"/>
-              <a:t>"name", </a:t>
-            </a:r>
-            <a:r>
-              <a:rPr lang="en-US" altLang="zh-TW"/>
-              <a:t>label = </a:t>
-            </a:r>
-            <a:r>
-              <a:rPr lang="zh-TW" altLang="zh-TW"/>
-              <a:t>"Your full name", value = "John Smith")</a:t>
-            </a:r>
-            <a:endParaRPr lang="zh-TW" altLang="en-US"/>
-          </a:p>
-        </p:txBody>
-      </p:sp>
-      <p:pic>
-        <p:nvPicPr>
-          <p:cNvPr id="9" name="圖片 8">
-            <a:extLst>
-              <a:ext uri="{FF2B5EF4-FFF2-40B4-BE49-F238E27FC236}">
-                <a16:creationId xmlns:a16="http://schemas.microsoft.com/office/drawing/2014/main" id="{052AB2CA-1CA4-B0F8-F7B6-8D200AE77FBA}"/>
-              </a:ext>
-            </a:extLst>
-          </p:cNvPr>
-          <p:cNvPicPr>
-            <a:picLocks noChangeAspect="1"/>
-          </p:cNvPicPr>
-          <p:nvPr/>
-        </p:nvPicPr>
-        <p:blipFill>
-          <a:blip r:embed="rId2"/>
-          <a:stretch>
-            <a:fillRect/>
-          </a:stretch>
-        </p:blipFill>
-        <p:spPr>
-          <a:xfrm>
-            <a:off x="3992697" y="4855602"/>
-            <a:ext cx="4206605" cy="1089754"/>
-          </a:xfrm>
-          <a:prstGeom prst="rect">
-            <a:avLst/>
-          </a:prstGeom>
-        </p:spPr>
-      </p:pic>
-      <p:sp>
-        <p:nvSpPr>
-          <p:cNvPr id="19" name="文字方塊 18">
-            <a:extLst>
-              <a:ext uri="{FF2B5EF4-FFF2-40B4-BE49-F238E27FC236}">
-                <a16:creationId xmlns:a16="http://schemas.microsoft.com/office/drawing/2014/main" id="{581C790A-BA5E-6DC1-6A10-09CCB900C60F}"/>
-              </a:ext>
-            </a:extLst>
-          </p:cNvPr>
-          <p:cNvSpPr txBox="1"/>
-          <p:nvPr/>
-        </p:nvSpPr>
-        <p:spPr>
-          <a:xfrm>
-            <a:off x="521110" y="3429000"/>
-            <a:ext cx="3097161" cy="461665"/>
-          </a:xfrm>
-          <a:prstGeom prst="rect">
-            <a:avLst/>
-          </a:prstGeom>
-          <a:noFill/>
-        </p:spPr>
-        <p:txBody>
-          <a:bodyPr wrap="square" rtlCol="0">
-            <a:spAutoFit/>
-          </a:bodyPr>
-          <a:lstStyle/>
-          <a:p>
-            <a:r>
-              <a:rPr lang="en-US" altLang="zh-TW" sz="2400">
-                <a:latin typeface="Arial" panose="020B0604020202020204" pitchFamily="34" charset="0"/>
-                <a:cs typeface="Arial" panose="020B0604020202020204" pitchFamily="34" charset="0"/>
-              </a:rPr>
-              <a:t>Example: </a:t>
-            </a:r>
-            <a:endParaRPr lang="zh-TW" altLang="en-US" sz="2400">
-              <a:latin typeface="Arial" panose="020B0604020202020204" pitchFamily="34" charset="0"/>
-              <a:cs typeface="Arial" panose="020B0604020202020204" pitchFamily="34" charset="0"/>
-            </a:endParaRPr>
-          </a:p>
-        </p:txBody>
-      </p:sp>
-    </p:spTree>
-    <p:extLst>
-      <p:ext uri="{BB962C8B-B14F-4D97-AF65-F5344CB8AC3E}">
-        <p14:creationId xmlns:p14="http://schemas.microsoft.com/office/powerpoint/2010/main" val="967130390"/>
       </p:ext>
     </p:extLst>
   </p:cSld>

</xml_diff>